<commit_message>
docs: add React Native into master evaluation deck
</commit_message>
<xml_diff>
--- a/1_Month_Training_Executive_Evaluation.pptx
+++ b/1_Month_Training_Executive_Evaluation.pptx
@@ -3591,7 +3591,7 @@
                 </a:solidFill>
                 <a:latin typeface="Segoe UI"/>
               </a:rPr>
-              <a:t>Week 4: Next.js &amp; Full-Stack
+              <a:t>Week 4: Next.js &amp; React Native
 </a:t>
             </a:r>
           </a:p>
@@ -3609,6 +3609,22 @@
                 <a:latin typeface="Segoe UI"/>
               </a:rPr>
               <a:t>• Next.js 14 App Router &amp; Server/Client Components</a:t>
+            </a:r>
+          </a:p>
+          <a:p>
+            <a:pPr algn="l">
+              <a:spcAft>
+                <a:spcPts val="500"/>
+              </a:spcAft>
+            </a:pPr>
+            <a:r>
+              <a:rPr sz="1200">
+                <a:solidFill>
+                  <a:srgbClr val="E2E8F0"/>
+                </a:solidFill>
+                <a:latin typeface="Segoe UI"/>
+              </a:rPr>
+              <a:t>• React Native &amp; Expo (Native Android Mobile App)</a:t>
             </a:r>
           </a:p>
           <a:p>
@@ -4163,7 +4179,7 @@
                 </a:solidFill>
                 <a:latin typeface="Segoe UI"/>
               </a:rPr>
-              <a:t>Mobile UX &amp; Performance
+              <a:t>Mobile UX &amp; React Native
 </a:t>
             </a:r>
           </a:p>
@@ -4180,6 +4196,22 @@
                 </a:solidFill>
                 <a:latin typeface="Segoe UI"/>
               </a:rPr>
+              <a:t>• React Native &amp; Expo Standalone Android App</a:t>
+            </a:r>
+          </a:p>
+          <a:p>
+            <a:pPr algn="l">
+              <a:spcAft>
+                <a:spcPts val="500"/>
+              </a:spcAft>
+            </a:pPr>
+            <a:r>
+              <a:rPr sz="1200">
+                <a:solidFill>
+                  <a:srgbClr val="E2E8F0"/>
+                </a:solidFill>
+                <a:latin typeface="Segoe UI"/>
+              </a:rPr>
               <a:t>• PWA-grade Mobile App Simulator &amp; Responsive Web</a:t>
             </a:r>
           </a:p>
@@ -4212,23 +4244,7 @@
                 </a:solidFill>
                 <a:latin typeface="Segoe UI"/>
               </a:rPr>
-              <a:t>• Clean subviews for Saved Listings &amp; My Ads Management</a:t>
-            </a:r>
-          </a:p>
-          <a:p>
-            <a:pPr algn="l">
-              <a:spcAft>
-                <a:spcPts val="500"/>
-              </a:spcAft>
-            </a:pPr>
-            <a:r>
-              <a:rPr sz="1200">
-                <a:solidFill>
-                  <a:srgbClr val="E2E8F0"/>
-                </a:solidFill>
-                <a:latin typeface="Segoe UI"/>
-              </a:rPr>
-              <a:t>• Universal zero-barrier Login &amp; Registration flow</a:t>
+              <a:t>• Universal zero-barrier Login &amp; Sub-views Management</a:t>
             </a:r>
           </a:p>
         </p:txBody>

</xml_diff>

<commit_message>
docs: streamline slide deck structure to eliminate redundancy
</commit_message>
<xml_diff>
--- a/1_Month_Training_Executive_Evaluation.pptx
+++ b/1_Month_Training_Executive_Evaluation.pptx
@@ -3264,7 +3264,7 @@
                 </a:solidFill>
                 <a:latin typeface="Segoe UI"/>
               </a:rPr>
-              <a:t>1-MONTH TECHNICAL EVALUATION</a:t>
+              <a:t>TRAINING JOURNEY</a:t>
             </a:r>
           </a:p>
         </p:txBody>
@@ -3386,7 +3386,7 @@
                 </a:solidFill>
                 <a:latin typeface="Segoe UI"/>
               </a:rPr>
-              <a:t>• CSS Grid, Flexbox, Glassmorphism &amp; Custom Properties</a:t>
+              <a:t>• CSS Grid, Flexbox, Glassmorphism &amp; Custom Tokens</a:t>
             </a:r>
           </a:p>
           <a:p>
@@ -3733,7 +3733,7 @@
                 </a:solidFill>
                 <a:latin typeface="Segoe UI"/>
               </a:rPr>
-              <a:t>1-MONTH TECHNICAL EVALUATION</a:t>
+              <a:t>THE PROBLEM &amp; SOLUTION</a:t>
             </a:r>
           </a:p>
         </p:txBody>
@@ -3768,7 +3768,373 @@
                 </a:solidFill>
                 <a:latin typeface="Segoe UI"/>
               </a:rPr>
-              <a:t>Full-Stack Architecture &amp; Production Stack</a:t>
+              <a:t>Capstone Project: ToLetNest Ecosystem</a:t>
+            </a:r>
+          </a:p>
+        </p:txBody>
+      </p:sp>
+      <p:sp>
+        <p:nvSpPr>
+          <p:cNvPr id="4" name="Rounded Rectangle 3"/>
+          <p:cNvSpPr/>
+          <p:nvPr/>
+        </p:nvSpPr>
+        <p:spPr>
+          <a:xfrm>
+            <a:off x="548640" y="1554480"/>
+            <a:ext cx="5303520" cy="4572000"/>
+          </a:xfrm>
+          <a:prstGeom prst="roundRect">
+            <a:avLst/>
+          </a:prstGeom>
+          <a:solidFill>
+            <a:srgbClr val="1E293B"/>
+          </a:solidFill>
+          <a:ln>
+            <a:solidFill>
+              <a:srgbClr val="334155"/>
+            </a:solidFill>
+          </a:ln>
+        </p:spPr>
+        <p:style>
+          <a:lnRef idx="1">
+            <a:schemeClr val="accent1"/>
+          </a:lnRef>
+          <a:fillRef idx="3">
+            <a:schemeClr val="accent1"/>
+          </a:fillRef>
+          <a:effectRef idx="2">
+            <a:schemeClr val="accent1"/>
+          </a:effectRef>
+          <a:fontRef idx="minor">
+            <a:schemeClr val="lt1"/>
+          </a:fontRef>
+        </p:style>
+        <p:txBody>
+          <a:bodyPr rtlCol="0" anchor="ctr" wrap="square" lIns="182880" rIns="182880" tIns="182880"/>
+          <a:lstStyle/>
+          <a:p>
+            <a:pPr algn="l"/>
+            <a:r>
+              <a:rPr sz="1700" b="1">
+                <a:solidFill>
+                  <a:srgbClr val="F43F5E"/>
+                </a:solidFill>
+                <a:latin typeface="Segoe UI"/>
+              </a:rPr>
+              <a:t>The Dhaka Rental Struggle
+</a:t>
+            </a:r>
+          </a:p>
+          <a:p>
+            <a:pPr algn="l">
+              <a:spcAft>
+                <a:spcPts val="500"/>
+              </a:spcAft>
+            </a:pPr>
+            <a:r>
+              <a:rPr sz="1200">
+                <a:solidFill>
+                  <a:srgbClr val="E2E8F0"/>
+                </a:solidFill>
+                <a:latin typeface="Segoe UI"/>
+              </a:rPr>
+              <a:t>• Scattered social media posts without verified map locations</a:t>
+            </a:r>
+          </a:p>
+          <a:p>
+            <a:pPr algn="l">
+              <a:spcAft>
+                <a:spcPts val="500"/>
+              </a:spcAft>
+            </a:pPr>
+            <a:r>
+              <a:rPr sz="1200">
+                <a:solidFill>
+                  <a:srgbClr val="E2E8F0"/>
+                </a:solidFill>
+                <a:latin typeface="Segoe UI"/>
+              </a:rPr>
+              <a:t>• Hidden utility costs causing disputes between roommates &amp; hosts</a:t>
+            </a:r>
+          </a:p>
+          <a:p>
+            <a:pPr algn="l">
+              <a:spcAft>
+                <a:spcPts val="500"/>
+              </a:spcAft>
+            </a:pPr>
+            <a:r>
+              <a:rPr sz="1200">
+                <a:solidFill>
+                  <a:srgbClr val="E2E8F0"/>
+                </a:solidFill>
+                <a:latin typeface="Segoe UI"/>
+              </a:rPr>
+              <a:t>• Privacy risks: public phone numbers exposed to unwanted calls</a:t>
+            </a:r>
+          </a:p>
+          <a:p>
+            <a:pPr algn="l">
+              <a:spcAft>
+                <a:spcPts val="500"/>
+              </a:spcAft>
+            </a:pPr>
+            <a:r>
+              <a:rPr sz="1200">
+                <a:solidFill>
+                  <a:srgbClr val="E2E8F0"/>
+                </a:solidFill>
+                <a:latin typeface="Segoe UI"/>
+              </a:rPr>
+              <a:t>• High broker fees &amp; lack of student-friendly seat transfer options</a:t>
+            </a:r>
+          </a:p>
+        </p:txBody>
+      </p:sp>
+      <p:sp>
+        <p:nvSpPr>
+          <p:cNvPr id="5" name="Rounded Rectangle 4"/>
+          <p:cNvSpPr/>
+          <p:nvPr/>
+        </p:nvSpPr>
+        <p:spPr>
+          <a:xfrm>
+            <a:off x="6217920" y="1554480"/>
+            <a:ext cx="5303520" cy="4572000"/>
+          </a:xfrm>
+          <a:prstGeom prst="roundRect">
+            <a:avLst/>
+          </a:prstGeom>
+          <a:solidFill>
+            <a:srgbClr val="1E293B"/>
+          </a:solidFill>
+          <a:ln>
+            <a:solidFill>
+              <a:srgbClr val="334155"/>
+            </a:solidFill>
+          </a:ln>
+        </p:spPr>
+        <p:style>
+          <a:lnRef idx="1">
+            <a:schemeClr val="accent1"/>
+          </a:lnRef>
+          <a:fillRef idx="3">
+            <a:schemeClr val="accent1"/>
+          </a:fillRef>
+          <a:effectRef idx="2">
+            <a:schemeClr val="accent1"/>
+          </a:effectRef>
+          <a:fontRef idx="minor">
+            <a:schemeClr val="lt1"/>
+          </a:fontRef>
+        </p:style>
+        <p:txBody>
+          <a:bodyPr rtlCol="0" anchor="ctr" wrap="square" lIns="182880" rIns="182880" tIns="182880"/>
+          <a:lstStyle/>
+          <a:p>
+            <a:pPr algn="l"/>
+            <a:r>
+              <a:rPr sz="1700" b="1">
+                <a:solidFill>
+                  <a:srgbClr val="10B981"/>
+                </a:solidFill>
+                <a:latin typeface="Segoe UI"/>
+              </a:rPr>
+              <a:t>The ToLetNest Innovation
+</a:t>
+            </a:r>
+          </a:p>
+          <a:p>
+            <a:pPr algn="l">
+              <a:spcAft>
+                <a:spcPts val="500"/>
+              </a:spcAft>
+            </a:pPr>
+            <a:r>
+              <a:rPr sz="1200">
+                <a:solidFill>
+                  <a:srgbClr val="E2E8F0"/>
+                </a:solidFill>
+                <a:latin typeface="Segoe UI"/>
+              </a:rPr>
+              <a:t>• Live GPS Radar Map centered on TechDojo &amp; Dhaka education hubs</a:t>
+            </a:r>
+          </a:p>
+          <a:p>
+            <a:pPr algn="l">
+              <a:spcAft>
+                <a:spcPts val="500"/>
+              </a:spcAft>
+            </a:pPr>
+            <a:r>
+              <a:rPr sz="1200">
+                <a:solidFill>
+                  <a:srgbClr val="E2E8F0"/>
+                </a:solidFill>
+                <a:latin typeface="Segoe UI"/>
+              </a:rPr>
+              <a:t>• Interactive pin-drop posting directly on Leaflet OpenStreetMap</a:t>
+            </a:r>
+          </a:p>
+          <a:p>
+            <a:pPr algn="l">
+              <a:spcAft>
+                <a:spcPts val="500"/>
+              </a:spcAft>
+            </a:pPr>
+            <a:r>
+              <a:rPr sz="1200">
+                <a:solidFill>
+                  <a:srgbClr val="E2E8F0"/>
+                </a:solidFill>
+                <a:latin typeface="Segoe UI"/>
+              </a:rPr>
+              <a:t>• Transparent itemized utility breakdown calculator</a:t>
+            </a:r>
+          </a:p>
+          <a:p>
+            <a:pPr algn="l">
+              <a:spcAft>
+                <a:spcPts val="500"/>
+              </a:spcAft>
+            </a:pPr>
+            <a:r>
+              <a:rPr sz="1200">
+                <a:solidFill>
+                  <a:srgbClr val="E2E8F0"/>
+                </a:solidFill>
+                <a:latin typeface="Segoe UI"/>
+              </a:rPr>
+              <a:t>• Masked phone numbers with in-app private chat &amp; simulated call</a:t>
+            </a:r>
+          </a:p>
+          <a:p>
+            <a:pPr algn="l">
+              <a:spcAft>
+                <a:spcPts val="500"/>
+              </a:spcAft>
+            </a:pPr>
+            <a:r>
+              <a:rPr sz="1200">
+                <a:solidFill>
+                  <a:srgbClr val="E2E8F0"/>
+                </a:solidFill>
+                <a:latin typeface="Segoe UI"/>
+              </a:rPr>
+              <a:t>• Dedicated ad management with status toggle &amp; instant delete</a:t>
+            </a:r>
+          </a:p>
+          <a:p>
+            <a:pPr algn="l">
+              <a:spcAft>
+                <a:spcPts val="500"/>
+              </a:spcAft>
+            </a:pPr>
+            <a:r>
+              <a:rPr sz="1200">
+                <a:solidFill>
+                  <a:srgbClr val="E2E8F0"/>
+                </a:solidFill>
+                <a:latin typeface="Segoe UI"/>
+              </a:rPr>
+              <a:t>• Live on Vercel: https://tolet-nest.vercel.app</a:t>
+            </a:r>
+          </a:p>
+        </p:txBody>
+      </p:sp>
+    </p:spTree>
+  </p:cSld>
+  <p:clrMapOvr>
+    <a:masterClrMapping/>
+  </p:clrMapOvr>
+</p:sld>
+</file>
+
+<file path=ppt/slides/slide4.xml><?xml version="1.0" encoding="utf-8"?>
+<p:sld xmlns:a="http://schemas.openxmlformats.org/drawingml/2006/main" xmlns:p="http://schemas.openxmlformats.org/presentationml/2006/main" xmlns:r="http://schemas.openxmlformats.org/officeDocument/2006/relationships">
+  <p:cSld>
+    <p:bg>
+      <p:bgPr>
+        <a:solidFill>
+          <a:srgbClr val="0F172A"/>
+        </a:solidFill>
+        <a:effectLst/>
+      </p:bgPr>
+    </p:bg>
+    <p:spTree>
+      <p:nvGrpSpPr>
+        <p:cNvPr id="1" name=""/>
+        <p:cNvGrpSpPr/>
+        <p:nvPr/>
+      </p:nvGrpSpPr>
+      <p:grpSpPr/>
+      <p:sp>
+        <p:nvSpPr>
+          <p:cNvPr id="2" name="TextBox 1"/>
+          <p:cNvSpPr txBox="1"/>
+          <p:nvPr/>
+        </p:nvSpPr>
+        <p:spPr>
+          <a:xfrm>
+            <a:off x="548640" y="365760"/>
+            <a:ext cx="9144000" cy="320040"/>
+          </a:xfrm>
+          <a:prstGeom prst="rect">
+            <a:avLst/>
+          </a:prstGeom>
+          <a:noFill/>
+        </p:spPr>
+        <p:txBody>
+          <a:bodyPr wrap="square">
+            <a:spAutoFit/>
+          </a:bodyPr>
+          <a:lstStyle/>
+          <a:p>
+            <a:pPr algn="l"/>
+            <a:r>
+              <a:rPr sz="1100" b="1">
+                <a:solidFill>
+                  <a:srgbClr val="10B981"/>
+                </a:solidFill>
+                <a:latin typeface="Segoe UI"/>
+              </a:rPr>
+              <a:t>SYSTEM ARCHITECTURE</a:t>
+            </a:r>
+          </a:p>
+        </p:txBody>
+      </p:sp>
+      <p:sp>
+        <p:nvSpPr>
+          <p:cNvPr id="3" name="TextBox 2"/>
+          <p:cNvSpPr txBox="1"/>
+          <p:nvPr/>
+        </p:nvSpPr>
+        <p:spPr>
+          <a:xfrm>
+            <a:off x="548640" y="685800"/>
+            <a:ext cx="10058400" cy="640080"/>
+          </a:xfrm>
+          <a:prstGeom prst="rect">
+            <a:avLst/>
+          </a:prstGeom>
+          <a:noFill/>
+        </p:spPr>
+        <p:txBody>
+          <a:bodyPr wrap="square">
+            <a:spAutoFit/>
+          </a:bodyPr>
+          <a:lstStyle/>
+          <a:p>
+            <a:pPr algn="l"/>
+            <a:r>
+              <a:rPr sz="2600" b="1">
+                <a:solidFill>
+                  <a:srgbClr val="FFFFFF"/>
+                </a:solidFill>
+                <a:latin typeface="Segoe UI"/>
+              </a:rPr>
+              <a:t>ToLetNest Technical Architecture &amp; Production Stack</a:t>
             </a:r>
           </a:p>
         </p:txBody>
@@ -3822,7 +4188,7 @@
                 </a:solidFill>
                 <a:latin typeface="Segoe UI"/>
               </a:rPr>
-              <a:t>Frontend Ecosystem
+              <a:t>Frontend &amp; Maps Layer
 </a:t>
             </a:r>
           </a:p>
@@ -3941,7 +4307,7 @@
                 </a:solidFill>
                 <a:latin typeface="Segoe UI"/>
               </a:rPr>
-              <a:t>Backend &amp; Serverless Layer
+              <a:t>Backend &amp; Serverless APIs
 </a:t>
             </a:r>
           </a:p>
@@ -3990,23 +4356,23 @@
                 </a:solidFill>
                 <a:latin typeface="Segoe UI"/>
               </a:rPr>
-              <a:t>• JSON validation, error boundaries, resilient fallbacks</a:t>
-            </a:r>
-          </a:p>
-          <a:p>
-            <a:pPr algn="l">
-              <a:spcAft>
-                <a:spcPts val="500"/>
-              </a:spcAft>
-            </a:pPr>
-            <a:r>
-              <a:rPr sz="1200">
-                <a:solidFill>
-                  <a:srgbClr val="E2E8F0"/>
-                </a:solidFill>
-                <a:latin typeface="Segoe UI"/>
-              </a:rPr>
-              <a:t>• Zero-phone-exposure simulated in-app calling</a:t>
+              <a:t>• JSON schema validation &amp; resilient error boundaries</a:t>
+            </a:r>
+          </a:p>
+          <a:p>
+            <a:pPr algn="l">
+              <a:spcAft>
+                <a:spcPts val="500"/>
+              </a:spcAft>
+            </a:pPr>
+            <a:r>
+              <a:rPr sz="1200">
+                <a:solidFill>
+                  <a:srgbClr val="E2E8F0"/>
+                </a:solidFill>
+                <a:latin typeface="Segoe UI"/>
+              </a:rPr>
+              <a:t>• Zero-phone-exposure simulated in-app calling protocol</a:t>
             </a:r>
           </a:p>
         </p:txBody>
@@ -4257,372 +4623,6 @@
 </p:sld>
 </file>
 
-<file path=ppt/slides/slide4.xml><?xml version="1.0" encoding="utf-8"?>
-<p:sld xmlns:a="http://schemas.openxmlformats.org/drawingml/2006/main" xmlns:p="http://schemas.openxmlformats.org/presentationml/2006/main" xmlns:r="http://schemas.openxmlformats.org/officeDocument/2006/relationships">
-  <p:cSld>
-    <p:bg>
-      <p:bgPr>
-        <a:solidFill>
-          <a:srgbClr val="0F172A"/>
-        </a:solidFill>
-        <a:effectLst/>
-      </p:bgPr>
-    </p:bg>
-    <p:spTree>
-      <p:nvGrpSpPr>
-        <p:cNvPr id="1" name=""/>
-        <p:cNvGrpSpPr/>
-        <p:nvPr/>
-      </p:nvGrpSpPr>
-      <p:grpSpPr/>
-      <p:sp>
-        <p:nvSpPr>
-          <p:cNvPr id="2" name="TextBox 1"/>
-          <p:cNvSpPr txBox="1"/>
-          <p:nvPr/>
-        </p:nvSpPr>
-        <p:spPr>
-          <a:xfrm>
-            <a:off x="548640" y="365760"/>
-            <a:ext cx="9144000" cy="320040"/>
-          </a:xfrm>
-          <a:prstGeom prst="rect">
-            <a:avLst/>
-          </a:prstGeom>
-          <a:noFill/>
-        </p:spPr>
-        <p:txBody>
-          <a:bodyPr wrap="square">
-            <a:spAutoFit/>
-          </a:bodyPr>
-          <a:lstStyle/>
-          <a:p>
-            <a:pPr algn="l"/>
-            <a:r>
-              <a:rPr sz="1100" b="1">
-                <a:solidFill>
-                  <a:srgbClr val="10B981"/>
-                </a:solidFill>
-                <a:latin typeface="Segoe UI"/>
-              </a:rPr>
-              <a:t>1-MONTH TECHNICAL EVALUATION</a:t>
-            </a:r>
-          </a:p>
-        </p:txBody>
-      </p:sp>
-      <p:sp>
-        <p:nvSpPr>
-          <p:cNvPr id="3" name="TextBox 2"/>
-          <p:cNvSpPr txBox="1"/>
-          <p:nvPr/>
-        </p:nvSpPr>
-        <p:spPr>
-          <a:xfrm>
-            <a:off x="548640" y="685800"/>
-            <a:ext cx="10058400" cy="640080"/>
-          </a:xfrm>
-          <a:prstGeom prst="rect">
-            <a:avLst/>
-          </a:prstGeom>
-          <a:noFill/>
-        </p:spPr>
-        <p:txBody>
-          <a:bodyPr wrap="square">
-            <a:spAutoFit/>
-          </a:bodyPr>
-          <a:lstStyle/>
-          <a:p>
-            <a:pPr algn="l"/>
-            <a:r>
-              <a:rPr sz="2600" b="1">
-                <a:solidFill>
-                  <a:srgbClr val="FFFFFF"/>
-                </a:solidFill>
-                <a:latin typeface="Segoe UI"/>
-              </a:rPr>
-              <a:t>Capstone Project: ToLetNest Ecosystem</a:t>
-            </a:r>
-          </a:p>
-        </p:txBody>
-      </p:sp>
-      <p:sp>
-        <p:nvSpPr>
-          <p:cNvPr id="4" name="Rounded Rectangle 3"/>
-          <p:cNvSpPr/>
-          <p:nvPr/>
-        </p:nvSpPr>
-        <p:spPr>
-          <a:xfrm>
-            <a:off x="548640" y="1554480"/>
-            <a:ext cx="5303520" cy="4572000"/>
-          </a:xfrm>
-          <a:prstGeom prst="roundRect">
-            <a:avLst/>
-          </a:prstGeom>
-          <a:solidFill>
-            <a:srgbClr val="1E293B"/>
-          </a:solidFill>
-          <a:ln>
-            <a:solidFill>
-              <a:srgbClr val="334155"/>
-            </a:solidFill>
-          </a:ln>
-        </p:spPr>
-        <p:style>
-          <a:lnRef idx="1">
-            <a:schemeClr val="accent1"/>
-          </a:lnRef>
-          <a:fillRef idx="3">
-            <a:schemeClr val="accent1"/>
-          </a:fillRef>
-          <a:effectRef idx="2">
-            <a:schemeClr val="accent1"/>
-          </a:effectRef>
-          <a:fontRef idx="minor">
-            <a:schemeClr val="lt1"/>
-          </a:fontRef>
-        </p:style>
-        <p:txBody>
-          <a:bodyPr rtlCol="0" anchor="ctr" wrap="square" lIns="182880" rIns="182880" tIns="182880"/>
-          <a:lstStyle/>
-          <a:p>
-            <a:pPr algn="l"/>
-            <a:r>
-              <a:rPr sz="1700" b="1">
-                <a:solidFill>
-                  <a:srgbClr val="F43F5E"/>
-                </a:solidFill>
-                <a:latin typeface="Segoe UI"/>
-              </a:rPr>
-              <a:t>The Problem in Dhaka
-</a:t>
-            </a:r>
-          </a:p>
-          <a:p>
-            <a:pPr algn="l">
-              <a:spcAft>
-                <a:spcPts val="500"/>
-              </a:spcAft>
-            </a:pPr>
-            <a:r>
-              <a:rPr sz="1200">
-                <a:solidFill>
-                  <a:srgbClr val="E2E8F0"/>
-                </a:solidFill>
-                <a:latin typeface="Segoe UI"/>
-              </a:rPr>
-              <a:t>• Unorganized social media posts without verified map locations</a:t>
-            </a:r>
-          </a:p>
-          <a:p>
-            <a:pPr algn="l">
-              <a:spcAft>
-                <a:spcPts val="500"/>
-              </a:spcAft>
-            </a:pPr>
-            <a:r>
-              <a:rPr sz="1200">
-                <a:solidFill>
-                  <a:srgbClr val="E2E8F0"/>
-                </a:solidFill>
-                <a:latin typeface="Segoe UI"/>
-              </a:rPr>
-              <a:t>• Hidden utility costs causing bitter tenant-landlord disputes</a:t>
-            </a:r>
-          </a:p>
-          <a:p>
-            <a:pPr algn="l">
-              <a:spcAft>
-                <a:spcPts val="500"/>
-              </a:spcAft>
-            </a:pPr>
-            <a:r>
-              <a:rPr sz="1200">
-                <a:solidFill>
-                  <a:srgbClr val="E2E8F0"/>
-                </a:solidFill>
-                <a:latin typeface="Segoe UI"/>
-              </a:rPr>
-              <a:t>• Privacy risks: public phone numbers exposed to spam</a:t>
-            </a:r>
-          </a:p>
-          <a:p>
-            <a:pPr algn="l">
-              <a:spcAft>
-                <a:spcPts val="500"/>
-              </a:spcAft>
-            </a:pPr>
-            <a:r>
-              <a:rPr sz="1200">
-                <a:solidFill>
-                  <a:srgbClr val="E2E8F0"/>
-                </a:solidFill>
-                <a:latin typeface="Segoe UI"/>
-              </a:rPr>
-              <a:t>• High broker fees for students and interns</a:t>
-            </a:r>
-          </a:p>
-        </p:txBody>
-      </p:sp>
-      <p:sp>
-        <p:nvSpPr>
-          <p:cNvPr id="5" name="Rounded Rectangle 4"/>
-          <p:cNvSpPr/>
-          <p:nvPr/>
-        </p:nvSpPr>
-        <p:spPr>
-          <a:xfrm>
-            <a:off x="6217920" y="1554480"/>
-            <a:ext cx="5303520" cy="4572000"/>
-          </a:xfrm>
-          <a:prstGeom prst="roundRect">
-            <a:avLst/>
-          </a:prstGeom>
-          <a:solidFill>
-            <a:srgbClr val="1E293B"/>
-          </a:solidFill>
-          <a:ln>
-            <a:solidFill>
-              <a:srgbClr val="334155"/>
-            </a:solidFill>
-          </a:ln>
-        </p:spPr>
-        <p:style>
-          <a:lnRef idx="1">
-            <a:schemeClr val="accent1"/>
-          </a:lnRef>
-          <a:fillRef idx="3">
-            <a:schemeClr val="accent1"/>
-          </a:fillRef>
-          <a:effectRef idx="2">
-            <a:schemeClr val="accent1"/>
-          </a:effectRef>
-          <a:fontRef idx="minor">
-            <a:schemeClr val="lt1"/>
-          </a:fontRef>
-        </p:style>
-        <p:txBody>
-          <a:bodyPr rtlCol="0" anchor="ctr" wrap="square" lIns="182880" rIns="182880" tIns="182880"/>
-          <a:lstStyle/>
-          <a:p>
-            <a:pPr algn="l"/>
-            <a:r>
-              <a:rPr sz="1700" b="1">
-                <a:solidFill>
-                  <a:srgbClr val="10B981"/>
-                </a:solidFill>
-                <a:latin typeface="Segoe UI"/>
-              </a:rPr>
-              <a:t>The ToLetNest Solution
-</a:t>
-            </a:r>
-          </a:p>
-          <a:p>
-            <a:pPr algn="l">
-              <a:spcAft>
-                <a:spcPts val="500"/>
-              </a:spcAft>
-            </a:pPr>
-            <a:r>
-              <a:rPr sz="1200">
-                <a:solidFill>
-                  <a:srgbClr val="E2E8F0"/>
-                </a:solidFill>
-                <a:latin typeface="Segoe UI"/>
-              </a:rPr>
-              <a:t>• Live GPS Radar Map centered on TechDojo &amp; Dhaka hubs</a:t>
-            </a:r>
-          </a:p>
-          <a:p>
-            <a:pPr algn="l">
-              <a:spcAft>
-                <a:spcPts val="500"/>
-              </a:spcAft>
-            </a:pPr>
-            <a:r>
-              <a:rPr sz="1200">
-                <a:solidFill>
-                  <a:srgbClr val="E2E8F0"/>
-                </a:solidFill>
-                <a:latin typeface="Segoe UI"/>
-              </a:rPr>
-              <a:t>• Interactive pin-drop posting directly on the Leaflet map</a:t>
-            </a:r>
-          </a:p>
-          <a:p>
-            <a:pPr algn="l">
-              <a:spcAft>
-                <a:spcPts val="500"/>
-              </a:spcAft>
-            </a:pPr>
-            <a:r>
-              <a:rPr sz="1200">
-                <a:solidFill>
-                  <a:srgbClr val="E2E8F0"/>
-                </a:solidFill>
-                <a:latin typeface="Segoe UI"/>
-              </a:rPr>
-              <a:t>• Transparent itemized utility breakdown calculator</a:t>
-            </a:r>
-          </a:p>
-          <a:p>
-            <a:pPr algn="l">
-              <a:spcAft>
-                <a:spcPts val="500"/>
-              </a:spcAft>
-            </a:pPr>
-            <a:r>
-              <a:rPr sz="1200">
-                <a:solidFill>
-                  <a:srgbClr val="E2E8F0"/>
-                </a:solidFill>
-                <a:latin typeface="Segoe UI"/>
-              </a:rPr>
-              <a:t>• Masked phone numbers with in-app chat and voice call</a:t>
-            </a:r>
-          </a:p>
-          <a:p>
-            <a:pPr algn="l">
-              <a:spcAft>
-                <a:spcPts val="500"/>
-              </a:spcAft>
-            </a:pPr>
-            <a:r>
-              <a:rPr sz="1200">
-                <a:solidFill>
-                  <a:srgbClr val="E2E8F0"/>
-                </a:solidFill>
-                <a:latin typeface="Segoe UI"/>
-              </a:rPr>
-              <a:t>• Dedicated ad management with status toggle &amp; delete</a:t>
-            </a:r>
-          </a:p>
-          <a:p>
-            <a:pPr algn="l">
-              <a:spcAft>
-                <a:spcPts val="500"/>
-              </a:spcAft>
-            </a:pPr>
-            <a:r>
-              <a:rPr sz="1200">
-                <a:solidFill>
-                  <a:srgbClr val="E2E8F0"/>
-                </a:solidFill>
-                <a:latin typeface="Segoe UI"/>
-              </a:rPr>
-              <a:t>• Live production deployment: https://tolet-nest.vercel.app</a:t>
-            </a:r>
-          </a:p>
-        </p:txBody>
-      </p:sp>
-    </p:spTree>
-  </p:cSld>
-  <p:clrMapOvr>
-    <a:masterClrMapping/>
-  </p:clrMapOvr>
-</p:sld>
-</file>
-
 <file path=ppt/slides/slide5.xml><?xml version="1.0" encoding="utf-8"?>
 <p:sld xmlns:a="http://schemas.openxmlformats.org/drawingml/2006/main" xmlns:p="http://schemas.openxmlformats.org/presentationml/2006/main" xmlns:r="http://schemas.openxmlformats.org/officeDocument/2006/relationships">
   <p:cSld>
@@ -4671,7 +4671,7 @@
                 </a:solidFill>
                 <a:latin typeface="Segoe UI"/>
               </a:rPr>
-              <a:t>1-MONTH TECHNICAL EVALUATION</a:t>
+              <a:t>LIVE APPLICATION DEMO</a:t>
             </a:r>
           </a:p>
         </p:txBody>
@@ -5282,7 +5282,7 @@
                 </a:solidFill>
                 <a:latin typeface="Segoe UI"/>
               </a:rPr>
-              <a:t>1-MONTH TECHNICAL EVALUATION</a:t>
+              <a:t>TECHNICAL CHALLENGES SOLVED</a:t>
             </a:r>
           </a:p>
         </p:txBody>

</xml_diff>